<commit_message>
fix: Slide 1 subtitle spacing (24px → 45px gap)
</commit_message>
<xml_diff>
--- a/ArcGent-Presentation.pptx
+++ b/ArcGent-Presentation.pptx
@@ -1782,7 +1782,7 @@
         </p:nvSpPr>
         <p:spPr>
           <a:xfrm>
-            <a:off x="731520" y="4114800"/>
+            <a:off x="731520" y="4297680"/>
             <a:ext cx="7315200" cy="731520"/>
           </a:xfrm>
           <a:prstGeom prst="rect">
@@ -1797,7 +1797,7 @@
           <a:p>
             <a:pPr indent="0" marL="0">
               <a:lnSpc>
-                <a:spcPct val="140000"/>
+                <a:spcPct val="150000"/>
               </a:lnSpc>
               <a:buNone/>
             </a:pPr>
@@ -1817,7 +1817,7 @@
           <a:p>
             <a:pPr indent="0" marL="0">
               <a:lnSpc>
-                <a:spcPct val="140000"/>
+                <a:spcPct val="150000"/>
               </a:lnSpc>
               <a:buNone/>
             </a:pPr>

</xml_diff>